<commit_message>
fix: keep the emptied notes through the slide move, and repair the footers
The recommendation-system slide moved into the backup section, which shifted
every slide between it and the divider up by one. Three speaker notes had been
emptied against the previous order; they are re-applied at the new positions,
and the one kept on "What this cannot support" is untouched.

Five footers carried a hard-coded slide number rather than the automatic field,
so the moved slides announced the wrong position: 14 read 15, 15 read 16, 17
read 18, 18 read 19, and the moved slide itself read 14 at position 21.

Two figures in the notes of "What it concluded about ING" predate the current
run: the comparison uses 33 features, not 36, and ING carries 5.0 persuasion
levers per page against a peer mean of 1.7, not 3.7 - that figure is from
before blank rubric cells were read as scored zeros.
</commit_message>
<xml_diff>
--- a/docs/Banking_Campaigns_Comparator.pptx
+++ b/docs/Banking_Campaigns_Comparator.pptx
@@ -621,7 +621,7 @@
           <a:lstStyle/>
           <a:p>
             <a:r>
-              <a:t>THREE NUMBERS, all from the current-account comparison — 14 banks, 36 comparable features:</a:t>
+              <a:t>THREE NUMBERS, all from the current-account comparison — 14 banks, 33 comparable features:</a:t>
             </a:r>
           </a:p>
           <a:p>
@@ -646,7 +646,7 @@
           </a:p>
           <a:p>
             <a:r>
-              <a:t>THE SHAPE: two of the three are about removing things. ING's pages carry the densest persuasion in the set (3.7 levers per page vs 1.7). The advice is restraint, not more features.</a:t>
+              <a:t>THE SHAPE: two of the three are about removing things. ING's pages carry the densest persuasion in the set (5.0 levers per page vs 1.7). The advice is restraint, not more features.</a:t>
             </a:r>
           </a:p>
           <a:p>
@@ -1020,39 +1020,7 @@
         <p:txBody>
           <a:bodyPr/>
           <a:lstStyle/>
-          <a:p>
-            <a:r>
-              <a:rPr lang="en-US" dirty="0"/>
-              <a:t>"What you keep is an instrument: 104 documented features, a frozen contract, a pipeline that re-runs from stored snapshots, 423 tests. The next comparison costs days, not weeks — including next September's state-bond wave.</a:t>
-            </a:r>
-          </a:p>
-          <a:p>
-            <a:endParaRPr lang="en-US" dirty="0"/>
-          </a:p>
-          <a:p>
-            <a:r>
-              <a:rPr lang="en-US" dirty="0"/>
-              <a:t>Ten </a:t>
-            </a:r>
-            <a:r>
-              <a:rPr lang="en-US" dirty="0" err="1"/>
-              <a:t>prioritised</a:t>
-            </a:r>
-            <a:r>
-              <a:rPr lang="en-US" dirty="0"/>
-              <a:t> changes came out of this run, each traced to a feature and a page. None is a performance claim — no click data exists, so each is a hypothesis you can test.</a:t>
-            </a:r>
-          </a:p>
-          <a:p>
-            <a:endParaRPr lang="en-US" dirty="0"/>
-          </a:p>
-          <a:p>
-            <a:r>
-              <a:rPr lang="en-US" dirty="0"/>
-              <a:t>It is a proof of concept. Your questions are the useful part."</a:t>
-            </a:r>
-            <a:endParaRPr dirty="0"/>
-          </a:p>
+          <a:p/>
         </p:txBody>
       </p:sp>
     </p:spTree>
@@ -1369,12 +1337,7 @@
         <p:txBody>
           <a:bodyPr/>
           <a:lstStyle/>
-          <a:p>
-            <a:r>
-              <a:rPr lang="en-US" dirty="0"/>
-              <a:t>"Five stages: collect under a compliance gate, extract, derive, score, analyse. Every stage writes to the same frozen feature contract, so no number has a second definition anywhere in the chain."</a:t>
-            </a:r>
-          </a:p>
+          <a:p/>
         </p:txBody>
       </p:sp>
     </p:spTree>
@@ -1559,65 +1522,7 @@
         <p:txBody>
           <a:bodyPr/>
           <a:lstStyle/>
-          <a:p>
-            <a:r>
-              <a:rPr lang="en-US" dirty="0"/>
-              <a:t>On the traditional–challenger axis ING scores 0.41. Belfius sits at 0.28 below you, </a:t>
-            </a:r>
-            <a:r>
-              <a:rPr lang="en-US" dirty="0" err="1"/>
-              <a:t>Keytrade</a:t>
-            </a:r>
-            <a:r>
-              <a:rPr lang="en-US" dirty="0"/>
-              <a:t> at 0.55 above — and </a:t>
-            </a:r>
-            <a:r>
-              <a:rPr lang="en-US" dirty="0" err="1"/>
-              <a:t>Keytrade</a:t>
-            </a:r>
-            <a:r>
-              <a:rPr lang="en-US" dirty="0"/>
-              <a:t> is a challenger. You are the last incumbent on the axis before the challengers begin: the most challenger-like traditional bank in Belgium. The hybrid is not a claim, it is a position on a line.</a:t>
-            </a:r>
-          </a:p>
-          <a:p>
-            <a:r>
-              <a:rPr lang="en-US" dirty="0"/>
-              <a:t>Your targeting shows too. The personas named on your pack pages are mass market, student and expat. Across your whole page set, six of eight, including investor and retiree. The high-value segments are there in the copy.</a:t>
-            </a:r>
-          </a:p>
-          <a:p>
-            <a:r>
-              <a:rPr lang="en-US" dirty="0"/>
-              <a:t>But three signals separate you from everyone, and all three are pressure. Deadline language, the largest gap in the set. Persuasion levers. And the offer reads as clearly worth having. On the pages we measured, you are the loudest bank in Belgium. Next to a top-five NPS irritator, that's the finding."</a:t>
-            </a:r>
-          </a:p>
-          <a:p>
-            <a:endParaRPr lang="en-US" dirty="0"/>
-          </a:p>
-          <a:p>
-            <a:r>
-              <a:rPr lang="en-US" dirty="0"/>
-              <a:t>"Trust reads zero for thirteen banks of fourteen. That is measured, not missing — not one page in this family cites a branch network as a benefit, and the only two carrying an institutional or regulatory trust signal are </a:t>
-            </a:r>
-            <a:r>
-              <a:rPr lang="en-US" dirty="0" err="1"/>
-              <a:t>Revolut's</a:t>
-            </a:r>
-            <a:r>
-              <a:rPr lang="en-US" dirty="0"/>
-              <a:t> and </a:t>
-            </a:r>
-            <a:r>
-              <a:rPr lang="en-US" dirty="0" err="1"/>
-              <a:t>bunq's</a:t>
-            </a:r>
-            <a:r>
-              <a:rPr lang="en-US" dirty="0"/>
-              <a:t>. Both challengers. The asset a Tier-1 bank has and a neobank cannot copy is the one nobody is using on the page."</a:t>
-            </a:r>
-          </a:p>
+          <a:p/>
         </p:txBody>
       </p:sp>
     </p:spTree>
@@ -11486,7 +11391,7 @@
                 <a:ea typeface="Helvetica Neue" pitchFamily="34" charset="-122"/>
                 <a:cs typeface="Helvetica Neue" pitchFamily="34" charset="-120"/>
               </a:rPr>
-              <a:t>15</a:t>
+              <a:t>14</a:t>
             </a:r>
             <a:endParaRPr lang="en-US" sz="1000" dirty="0"/>
           </a:p>
@@ -12078,7 +11983,7 @@
                 <a:ea typeface="Helvetica Neue" pitchFamily="34" charset="-122"/>
                 <a:cs typeface="Helvetica Neue" pitchFamily="34" charset="-120"/>
               </a:rPr>
-              <a:t>16</a:t>
+              <a:t>15</a:t>
             </a:r>
             <a:endParaRPr lang="en-US" sz="1000" dirty="0"/>
           </a:p>
@@ -13827,7 +13732,7 @@
                 <a:ea typeface="Helvetica Neue" pitchFamily="34" charset="-122"/>
                 <a:cs typeface="Helvetica Neue" pitchFamily="34" charset="-120"/>
               </a:rPr>
-              <a:t>18</a:t>
+              <a:t>17</a:t>
             </a:r>
             <a:endParaRPr lang="en-US" sz="1000" dirty="0"/>
           </a:p>
@@ -14335,7 +14240,7 @@
                 </a:solidFill>
                 <a:latin typeface="Helvetica Neue"/>
               </a:rPr>
-              <a:t>19</a:t>
+              <a:t>18</a:t>
             </a:r>
           </a:p>
         </p:txBody>
@@ -15411,7 +15316,7 @@
                 <a:ea typeface="Helvetica Neue" pitchFamily="34" charset="-122"/>
                 <a:cs typeface="Helvetica Neue" pitchFamily="34" charset="-120"/>
               </a:rPr>
-              <a:t>14</a:t>
+              <a:t>21</a:t>
             </a:r>
             <a:endParaRPr lang="en-US" sz="1000" dirty="0"/>
           </a:p>

</xml_diff>

<commit_message>
fix: write the one remaining presenter note annotation in English
The deck is delivered in English and its slides already were; a note left on
'What this cannot support' still carried a French aside marking that paragraph
optional. Presenter view is the only place it showed, but it is the only French
left in the file.
</commit_message>
<xml_diff>
--- a/docs/Banking_Campaigns_Comparator.pptx
+++ b/docs/Banking_Campaigns_Comparator.pptx
@@ -951,12 +951,10 @@
           </a:p>
           <a:p>
             <a:r>
-              <a:t>OPTIONNEL, ~15 s, coupe si tu debordes : "That is why four of the five observations in your kickoff deck now read not testable rather than not supported. Three were being judged on a word-count band that reads 'long' for all fourteen banks — a measure that separates nobody cannot refute anyone. One claim is genuinely not supported: text is still beside the picture."</a:t>
-            </a:r>
-          </a:p>
-          <a:p>
-            <a:endParaRPr/>
-          </a:p>
+              <a:t>OPTIONAL, about 15 s, cut it if you are running long: "That is why four of the five observations in your kickoff deck now read not testable rather than not supported. Three were being judged on a word-count band that reads 'long' for all fourteen banks — a measure that separates nobody cannot refute anyone. One claim is genuinely not supported: text is still beside the picture."</a:t>
+            </a:r>
+          </a:p>
+          <a:p/>
           <a:p>
             <a:r>
               <a:t>And one whole axis of our AI Score returns nothing.</a:t>

</xml_diff>

<commit_message>
docs: speaker notes for the opening and the strategic context
Notes only - no slide content changes, 42 slides unchanged.
</commit_message>
<xml_diff>
--- a/docs/Banking_Campaigns_Comparator.pptx
+++ b/docs/Banking_Campaigns_Comparator.pptx
@@ -249,7 +249,7 @@
           <a:p>
             <a:fld id="{5EAA65B6-A2CF-4CB4-ADA6-4FB12DC6F514}" type="datetimeFigureOut">
               <a:rPr lang="fr-BE" smtClean="0"/>
-              <a:t>25/09/26</a:t>
+              <a:t>25-09-26</a:t>
             </a:fld>
             <a:endParaRPr lang="fr-BE"/>
           </a:p>
@@ -561,14 +561,73 @@
           <a:bodyPr/>
           <a:lstStyle/>
           <a:p>
-            <a:r>
-              <a:rPr lang="en-US" dirty="0"/>
-              <a:t>"As part of the ING DACI two-week P of C, we set out to answer one question: how do Belgian banks communicate similar products on the open web, and what can ING learn from it?  To move away from subjective design opinions, we built a fully reproducible, end-to-end measurement pipeline across 14 banks and 104 features. First disclaimer before we start: we have no internal data, nothing here claims a design choice caused a commercial outcome — every recommendation is an argued hypothesis worth testing. </a:t>
-            </a:r>
+            <a:pPr>
+              <a:lnSpc>
+                <a:spcPct val="115000"/>
+              </a:lnSpc>
+              <a:spcAft>
+                <a:spcPts val="800"/>
+              </a:spcAft>
+            </a:pPr>
+            <a:r>
+              <a:rPr lang="en-US" sz="1800" kern="100" dirty="0">
+                <a:effectLst/>
+                <a:latin typeface="Aptos" panose="020B0004020202020204" pitchFamily="34" charset="0"/>
+                <a:ea typeface="Aptos" panose="020B0004020202020204" pitchFamily="34" charset="0"/>
+                <a:cs typeface="Times New Roman" panose="02020603050405020304" pitchFamily="18" charset="0"/>
+              </a:rPr>
+              <a:t>As part of the ING DACI two-week P of C, we set out to answer one question: how do Belgian banks communicate about similar products on the open web, and what can ING learn from it? </a:t>
+            </a:r>
+            <a:endParaRPr lang="fr-BE" sz="1800" kern="100" dirty="0">
+              <a:effectLst/>
+              <a:latin typeface="Aptos" panose="020B0004020202020204" pitchFamily="34" charset="0"/>
+              <a:ea typeface="Aptos" panose="020B0004020202020204" pitchFamily="34" charset="0"/>
+              <a:cs typeface="Times New Roman" panose="02020603050405020304" pitchFamily="18" charset="0"/>
+            </a:endParaRPr>
+          </a:p>
+          <a:p>
+            <a:r>
+              <a:rPr lang="en-US" sz="1800" dirty="0">
+                <a:effectLst/>
+                <a:latin typeface="Aptos" panose="020B0004020202020204" pitchFamily="34" charset="0"/>
+                <a:ea typeface="Aptos" panose="020B0004020202020204" pitchFamily="34" charset="0"/>
+                <a:cs typeface="Times New Roman" panose="02020603050405020304" pitchFamily="18" charset="0"/>
+              </a:rPr>
+              <a:t>To move away from subjective design opinions, we built a fully reproducible, ..</a:t>
+            </a:r>
+            <a:endParaRPr lang="fr-BE" dirty="0"/>
+          </a:p>
+        </p:txBody>
+      </p:sp>
+      <p:sp>
+        <p:nvSpPr>
+          <p:cNvPr id="4" name="Slide Number Placeholder 3"/>
+          <p:cNvSpPr>
+            <a:spLocks noGrp="1"/>
+          </p:cNvSpPr>
+          <p:nvPr>
+            <p:ph type="sldNum" sz="quarter" idx="5"/>
+          </p:nvPr>
+        </p:nvSpPr>
+        <p:spPr/>
+        <p:txBody>
+          <a:bodyPr/>
+          <a:lstStyle/>
+          <a:p>
+            <a:fld id="{3BD8D499-DB7D-4F44-9C48-D7F5314CC23E}" type="slidenum">
+              <a:rPr lang="fr-BE" smtClean="0"/>
+              <a:t>1</a:t>
+            </a:fld>
+            <a:endParaRPr lang="fr-BE"/>
           </a:p>
         </p:txBody>
       </p:sp>
     </p:spTree>
+    <p:extLst>
+      <p:ext uri="{BB962C8B-B14F-4D97-AF65-F5344CB8AC3E}">
+        <p14:creationId xmlns:p14="http://schemas.microsoft.com/office/powerpoint/2010/main" val="3952029785"/>
+      </p:ext>
+    </p:extLst>
   </p:cSld>
   <p:clrMapOvr>
     <a:masterClrMapping/>
@@ -621,42 +680,42 @@
           <a:lstStyle/>
           <a:p>
             <a:r>
-              <a:t>THREE NUMBERS, all from the current-account comparison — 14 banks, 33 comparable features:</a:t>
-            </a:r>
-          </a:p>
-          <a:p>
-            <a:r>
-              <a:t>1. 4.0 urgency and deadline markers per page vs a peer mean of 0.64 — about 3.7 SD above, the largest gap in the set and ING's strongest measured signature.</a:t>
-            </a:r>
-          </a:p>
-          <a:p>
-            <a:r>
-              <a:t>2. Page height 11,149 px vs 6,412 — about 74% longer, so the offer sits further from the top (about 1.4 SD).</a:t>
-            </a:r>
-          </a:p>
-          <a:p>
-            <a:r>
-              <a:t>3. 0.67 'free' claims with their conditions elsewhere vs 0.23 — where a free or no-fee claim appears, the qualifying conditions are not next to it.</a:t>
-            </a:r>
-          </a:p>
-          <a:p>
-            <a:r>
-              <a:t>THE THREE IT RANKED HIGHEST: strip back urgency and deadline language · bring the offer higher up the page (the current run words it "shorten the pages and cut non-informative imagery" — same measure, page_height_px) · disclose the conditions of any free claim next to the claim.</a:t>
-            </a:r>
-          </a:p>
-          <a:p>
-            <a:r>
-              <a:t>THE SHAPE: two of the three are about removing things. ING's pages carry the densest persuasion in the set (5.0 levers per page vs 1.7). The advice is restraint, not more features.</a:t>
-            </a:r>
-          </a:p>
-          <a:p>
-            <a:r>
-              <a:t>CAVEAT — read it, do not skip it: design observations, not performance findings. Pages span product families and languages, judged features come from one rater, no click or conversion data — every item is a hypothesis ING could test.</a:t>
-            </a:r>
-          </a:p>
-          <a:p>
-            <a:r>
-              <a:t>TRANSITION: a list is easy to nod at and forget. So we built the thing.</a:t>
+              <a:t>WALK THE CARD (R1, top): title and priority · WHAT THE DATA SHOWS — the finding with its numbers: 4.0 urgency markers per page vs a peer mean of 0.64, about 3.7 SD · WHAT TO DO — the action · chips: the feature it was argued from (urgency_marker_count) and the pages it applies to.</a:t>
+            </a:r>
+          </a:p>
+          <a:p>
+            <a:r>
+              <a:t>THREE GUARDRAILS (right column):</a:t>
+            </a:r>
+          </a:p>
+          <a:p>
+            <a:r>
+              <a:t>1. Finding and action kept apart. Anyone can reject the action and keep the finding — nobody has to buy the advice to accept the measurement.</a:t>
+            </a:r>
+          </a:p>
+          <a:p>
+            <a:r>
+              <a:t>2. Named features, checked before release. Every feature id on a card is verified against the report; an id the model invented is dropped before the list is shown.</a:t>
+            </a:r>
+          </a:p>
+          <a:p>
+            <a:r>
+              <a:t>3. No figure the analysis did not produce. The prompt receives only numbers already in the report; the output is not trusted to add any.</a:t>
+            </a:r>
+          </a:p>
+          <a:p>
+            <a:r>
+              <a:t>ONE LINE: the model is a writer, not a source.</a:t>
+            </a:r>
+          </a:p>
+          <a:p>
+            <a:r>
+              <a:t>IF ASKED about R2 in the screenshot ("Repeat the primary call to action"): it rests on cta_count, withdrawn on 23/09 — the captured HTML holds every pack card, but no counting rule reproduced a human count across the fourteen banks, so the figure would have reported markup convention rather than the page. A recommendation dying with its feature is the mechanism working. The screenshot predates the withdrawal.</a:t>
+            </a:r>
+          </a:p>
+          <a:p>
+            <a:r>
+              <a:t>TRANSITION: so what did it conclude about ING?</a:t>
             </a:r>
           </a:p>
         </p:txBody>
@@ -726,42 +785,42 @@
           <a:lstStyle/>
           <a:p>
             <a:r>
-              <a:t>ON SCREEN: top — the generated home page in ING styling (hero, two calls to action). Bottom — one section in explained mode: orange frame, and the (i) button that opens the rationale for that section.</a:t>
-            </a:r>
-          </a:p>
-          <a:p>
-            <a:r>
-              <a:t>THREE POINTS:</a:t>
-            </a:r>
-          </a:p>
-          <a:p>
-            <a:r>
-              <a:t>1. The team chooses what gets built. Every recommendation is a checkbox; nothing reaches the generator that a person did not tick.</a:t>
-            </a:r>
-          </a:p>
-          <a:p>
-            <a:r>
-              <a:t>2. Ten ING-styled pages, fr-BE or nl-BE: home, savings, term account, current account, youth, investing, mortgage, opening, why ING, contact.</a:t>
-            </a:r>
-          </a:p>
-          <a:p>
-            <a:r>
-              <a:t>3. Each section can name its own source. Explained mode shows which recommendation produced the section and why — auditable, not just persuasive.</a:t>
-            </a:r>
-          </a:p>
-          <a:p>
-            <a:r>
-              <a:t>SAY PLAINLY: an illustration — generated, never published, not a proposal for ING's site. Rates and amounts stay as [TAUX] and [MONTANT]: no figure appears that a compliance team has not supplied.</a:t>
-            </a:r>
-          </a:p>
-          <a:p>
-            <a:r>
-              <a:t>ORANGE LINE: this is what makes the analysis arguable — a stakeholder can look at the change instead of reading about it. Invite it: "which of these would you untick?"</a:t>
-            </a:r>
-          </a:p>
-          <a:p>
-            <a:r>
-              <a:t>TRANSITION: put together, the whole thing runs in one direction.</a:t>
+              <a:t>THREE NUMBERS, all from the current-account comparison — 14 banks, 33 comparable features:</a:t>
+            </a:r>
+          </a:p>
+          <a:p>
+            <a:r>
+              <a:t>1. 4.0 urgency and deadline markers per page vs a peer mean of 0.64 — about 3.7 SD above, the largest gap in the set and ING's strongest measured signature.</a:t>
+            </a:r>
+          </a:p>
+          <a:p>
+            <a:r>
+              <a:t>2. Page height 11,149 px vs 6,412 — about 74% longer, so the offer sits further from the top (about 1.4 SD).</a:t>
+            </a:r>
+          </a:p>
+          <a:p>
+            <a:r>
+              <a:t>3. 0.67 'free' claims with their conditions elsewhere vs 0.23 — where a free or no-fee claim appears, the qualifying conditions are not next to it.</a:t>
+            </a:r>
+          </a:p>
+          <a:p>
+            <a:r>
+              <a:t>THE THREE IT RANKED HIGHEST: strip back urgency and deadline language · bring the offer higher up the page (the current run words it "shorten the pages and cut non-informative imagery" — same measure, page_height_px) · disclose the conditions of any free claim next to the claim.</a:t>
+            </a:r>
+          </a:p>
+          <a:p>
+            <a:r>
+              <a:t>THE SHAPE: two of the three are about removing things. ING's pages carry the densest persuasion in the set (5.0 levers per page vs 1.7). The advice is restraint, not more features.</a:t>
+            </a:r>
+          </a:p>
+          <a:p>
+            <a:r>
+              <a:t>CAVEAT — read it, do not skip it: design observations, not performance findings. Pages span product families and languages, judged features come from one rater, no click or conversion data — every item is a hypothesis ING could test.</a:t>
+            </a:r>
+          </a:p>
+          <a:p>
+            <a:r>
+              <a:t>TRANSITION: a list is easy to nod at and forget. So we built the thing.</a:t>
             </a:r>
           </a:p>
         </p:txBody>
@@ -831,32 +890,42 @@
           <a:lstStyle/>
           <a:p>
             <a:r>
-              <a:t>TOP ROW, stages 1–5 — the measurement half already walked: sources → capture (robots gate, pages rendered as a visitor sees them) → dataset with the human rubric scores → analysis → surfaces (report.json, the web UI). One arrow carries report.json down.</a:t>
-            </a:r>
-          </a:p>
-          <a:p>
-            <a:r>
-              <a:t>BOTTOM ROW, stages 6–8 — this section: recommendations (one model call, ordered list, each naming its features) → human selection (checkboxes; nothing proceeds unchosen) → generated site (ten pages, exactly the selected set, placeholders for every figure).</a:t>
-            </a:r>
-          </a:p>
-          <a:p>
-            <a:r>
-              <a:t>GREY BAND — read it as one sentence: the model sees only numbers the analysis produced; every recommendation names its features and is checked before it leaves the module; nothing is built that a human did not tick; news-theme items are context, never evidence; no performance data exists, so nothing here claims a cause.</a:t>
-            </a:r>
-          </a:p>
-          <a:p>
-            <a:r>
-              <a:t>WHY ONE DIRECTION MATTERS: every arrow is a script and can be re-run, so a correction made upstream flows all the way through. That is how the cta_count withdrawal propagated this week — once it was made in the analysis rather than patched into an output file.</a:t>
-            </a:r>
-          </a:p>
-          <a:p>
-            <a:r>
-              <a:t>NOTE: the diagram's "11 of 11 selected" and "11 ordered changes" predate the withdrawal — ten now.</a:t>
-            </a:r>
-          </a:p>
-          <a:p>
-            <a:r>
-              <a:t>TRANSITION to slide 18: that last guardrail — no performance data — is the limit of the whole project. Next slide.</a:t>
+              <a:t>ON SCREEN: top — the generated home page in ING styling (hero, two calls to action). Bottom — one section in explained mode: orange frame, and the (i) button that opens the rationale for that section.</a:t>
+            </a:r>
+          </a:p>
+          <a:p>
+            <a:r>
+              <a:t>THREE POINTS:</a:t>
+            </a:r>
+          </a:p>
+          <a:p>
+            <a:r>
+              <a:t>1. The team chooses what gets built. Every recommendation is a checkbox; nothing reaches the generator that a person did not tick.</a:t>
+            </a:r>
+          </a:p>
+          <a:p>
+            <a:r>
+              <a:t>2. Ten ING-styled pages, fr-BE or nl-BE: home, savings, term account, current account, youth, investing, mortgage, opening, why ING, contact.</a:t>
+            </a:r>
+          </a:p>
+          <a:p>
+            <a:r>
+              <a:t>3. Each section can name its own source. Explained mode shows which recommendation produced the section and why — auditable, not just persuasive.</a:t>
+            </a:r>
+          </a:p>
+          <a:p>
+            <a:r>
+              <a:t>SAY PLAINLY: an illustration — generated, never published, not a proposal for ING's site. Rates and amounts stay as [TAUX] and [MONTANT]: no figure appears that a compliance team has not supplied.</a:t>
+            </a:r>
+          </a:p>
+          <a:p>
+            <a:r>
+              <a:t>ORANGE LINE: this is what makes the analysis arguable — a stakeholder can look at the change instead of reading about it. Invite it: "which of these would you untick?"</a:t>
+            </a:r>
+          </a:p>
+          <a:p>
+            <a:r>
+              <a:t>TRANSITION: put together, the whole thing runs in one direction.</a:t>
             </a:r>
           </a:p>
         </p:txBody>
@@ -905,7 +974,7 @@
             <a:spLocks noGrp="1" noRot="1" noChangeAspect="1"/>
           </p:cNvSpPr>
           <p:nvPr>
-            <p:ph type="sldImg"/>
+            <p:ph type="sldImg" idx="2"/>
           </p:nvPr>
         </p:nvSpPr>
         <p:spPr/>
@@ -917,7 +986,7 @@
             <a:spLocks noGrp="1"/>
           </p:cNvSpPr>
           <p:nvPr>
-            <p:ph type="body" idx="1"/>
+            <p:ph type="body" sz="quarter" idx="3"/>
           </p:nvPr>
         </p:nvSpPr>
         <p:spPr/>
@@ -926,46 +995,47 @@
           <a:lstStyle/>
           <a:p>
             <a:r>
-              <a:t>"104 features in, 33 out. Every reduction is on screen.</a:t>
-            </a:r>
-          </a:p>
-          <a:p>
-            <a:r>
-              <a:t>And five withdrawn outright, because they measured our tooling, not your pages.</a:t>
-            </a:r>
-          </a:p>
-          <a:p>
-            <a:r>
-              <a:t>Calls to action: no counting rule held across fourteen banks. Navigation, repeated links, clickable cards — each bank marks them up differently.</a:t>
-            </a:r>
-          </a:p>
-          <a:p>
-            <a:r>
-              <a:t>Animation: our rule asked whether the stylesheet declared an animation, not whether the page moves. Across eighteen pages, exactly one has real motion — Revolut, a video. Your kickoff deck said ING was the only traditional bank animating. That is now marked not testable, not disproved. We will not rule on it with a broken instrument.</a:t>
-            </a:r>
-          </a:p>
-          <a:p>
-            <a:r>
-              <a:t>The fifth we found while rehearsing this: a feature that tested whether a page uses an HTML table element. Traditional banks do. N26 and Revolut build the same plan comparison in CSS. It was reporting a markup convention as a strategic difference.</a:t>
-            </a:r>
-          </a:p>
-          <a:p>
-            <a:r>
-              <a:t>OPTIONAL, about 15 s, cut it if you are running long: "That is why four of the five observations in your kickoff deck now read not testable rather than not supported. Three were being judged on a word-count band that reads 'long' for all fourteen banks — a measure that separates nobody cannot refute anyone. One claim is genuinely not supported: text is still beside the picture."</a:t>
-            </a:r>
-          </a:p>
-          <a:p/>
-          <a:p>
-            <a:r>
-              <a:t>And one whole axis of our AI Score returns nothing.</a:t>
-            </a:r>
-          </a:p>
-          <a:p>
-            <a:r>
-              <a:t>We would rather hand you 33 numbers we can defend."</a:t>
-            </a:r>
-          </a:p>
-        </p:txBody>
+              <a:t>TOP ROW, stages 1–5 — the measurement half already walked: sources → capture (robots gate, pages rendered as a visitor sees them) → dataset with the human rubric scores → analysis → surfaces (report.json, the web UI). One arrow carries report.json down.</a:t>
+            </a:r>
+          </a:p>
+          <a:p>
+            <a:r>
+              <a:t>BOTTOM ROW, stages 6–8 — this section: recommendations (one model call, ordered list, each naming its features) → human selection (checkboxes; nothing proceeds unchosen) → generated site (ten pages, exactly the selected set, placeholders for every figure).</a:t>
+            </a:r>
+          </a:p>
+          <a:p>
+            <a:r>
+              <a:t>GREY BAND — read it as one sentence: the model sees only numbers the analysis produced; every recommendation names its features and is checked before it leaves the module; nothing is built that a human did not tick; news-theme items are context, never evidence; no performance data exists, so nothing here claims a cause.</a:t>
+            </a:r>
+          </a:p>
+          <a:p>
+            <a:r>
+              <a:t>WHY ONE DIRECTION MATTERS: every arrow is a script and can be re-run, so a correction made upstream flows all the way through. That is how the cta_count withdrawal propagated this week — once it was made in the analysis rather than patched into an output file.</a:t>
+            </a:r>
+          </a:p>
+          <a:p>
+            <a:r>
+              <a:t>NOTE: the diagram's "11 of 11 selected" and "11 ordered changes" predate the withdrawal — ten now.</a:t>
+            </a:r>
+          </a:p>
+          <a:p>
+            <a:r>
+              <a:t>TRANSITION to slide 18: that last guardrail — no performance data — is the limit of the whole project. Next slide.</a:t>
+            </a:r>
+          </a:p>
+        </p:txBody>
+      </p:sp>
+      <p:sp>
+        <p:nvSpPr>
+          <p:cNvPr id="4" name="Slide Number Placeholder 3"/>
+          <p:cNvSpPr>
+            <a:spLocks noGrp="1"/>
+          </p:cNvSpPr>
+          <p:nvPr>
+            <p:ph type="sldNum" sz="quarter" idx="5"/>
+          </p:nvPr>
+        </p:nvSpPr>
+        <p:spPr/>
       </p:sp>
     </p:spTree>
   </p:cSld>
@@ -1018,7 +1088,49 @@
         <p:txBody>
           <a:bodyPr/>
           <a:lstStyle/>
-          <a:p/>
+          <a:p>
+            <a:r>
+              <a:t>"104 features in, 33 out. Every reduction is on screen.</a:t>
+            </a:r>
+          </a:p>
+          <a:p>
+            <a:r>
+              <a:t>And five withdrawn outright, because they measured our tooling, not your pages.</a:t>
+            </a:r>
+          </a:p>
+          <a:p>
+            <a:r>
+              <a:t>Calls to action: no counting rule held across fourteen banks. Navigation, repeated links, clickable cards — each bank marks them up differently.</a:t>
+            </a:r>
+          </a:p>
+          <a:p>
+            <a:r>
+              <a:t>Animation: our rule asked whether the stylesheet declared an animation, not whether the page moves. Across eighteen pages, exactly one has real motion — Revolut, a video. Your kickoff deck said ING was the only traditional bank animating. That is now marked not testable, not disproved. We will not rule on it with a broken instrument.</a:t>
+            </a:r>
+          </a:p>
+          <a:p>
+            <a:r>
+              <a:t>The fifth we found while rehearsing this: a feature that tested whether a page uses an HTML table element. Traditional banks do. N26 and Revolut build the same plan comparison in CSS. It was reporting a markup convention as a strategic difference.</a:t>
+            </a:r>
+          </a:p>
+          <a:p>
+            <a:r>
+              <a:t>OPTIONAL, about 15 s, cut it if you are running long: "That is why four of the five observations in your kickoff deck now read not testable rather than not supported. Three were being judged on a word-count band that reads 'long' for all fourteen banks — a measure that separates nobody cannot refute anyone. One claim is genuinely not supported: text is still beside the picture."</a:t>
+            </a:r>
+          </a:p>
+          <a:p>
+            <a:endParaRPr/>
+          </a:p>
+          <a:p>
+            <a:r>
+              <a:t>And one whole axis of our AI Score returns nothing.</a:t>
+            </a:r>
+          </a:p>
+          <a:p>
+            <a:r>
+              <a:t>We would rather hand you 33 numbers we can defend."</a:t>
+            </a:r>
+          </a:p>
         </p:txBody>
       </p:sp>
     </p:spTree>
@@ -1053,6 +1165,62 @@
             <a:spLocks noGrp="1" noRot="1" noChangeAspect="1"/>
           </p:cNvSpPr>
           <p:nvPr>
+            <p:ph type="sldImg"/>
+          </p:nvPr>
+        </p:nvSpPr>
+        <p:spPr/>
+      </p:sp>
+      <p:sp>
+        <p:nvSpPr>
+          <p:cNvPr id="3" name="Notes Placeholder 2"/>
+          <p:cNvSpPr>
+            <a:spLocks noGrp="1"/>
+          </p:cNvSpPr>
+          <p:nvPr>
+            <p:ph type="body" idx="1"/>
+          </p:nvPr>
+        </p:nvSpPr>
+        <p:spPr/>
+        <p:txBody>
+          <a:bodyPr/>
+          <a:lstStyle/>
+          <a:p>
+            <a:endParaRPr/>
+          </a:p>
+        </p:txBody>
+      </p:sp>
+    </p:spTree>
+  </p:cSld>
+  <p:clrMapOvr>
+    <a:masterClrMapping/>
+  </p:clrMapOvr>
+</p:notes>
+</file>
+
+<file path=ppt/notesSlides/notesSlide16.xml><?xml version="1.0" encoding="utf-8"?>
+<p:notes xmlns:a="http://schemas.openxmlformats.org/drawingml/2006/main" xmlns:r="http://schemas.openxmlformats.org/officeDocument/2006/relationships" xmlns:p="http://schemas.openxmlformats.org/presentationml/2006/main">
+  <p:cSld>
+    <p:spTree>
+      <p:nvGrpSpPr>
+        <p:cNvPr id="1" name=""/>
+        <p:cNvGrpSpPr/>
+        <p:nvPr/>
+      </p:nvGrpSpPr>
+      <p:grpSpPr>
+        <a:xfrm>
+          <a:off x="0" y="0"/>
+          <a:ext cx="0" cy="0"/>
+          <a:chOff x="0" y="0"/>
+          <a:chExt cx="0" cy="0"/>
+        </a:xfrm>
+      </p:grpSpPr>
+      <p:sp>
+        <p:nvSpPr>
+          <p:cNvPr id="2" name="Slide Image Placeholder 1"/>
+          <p:cNvSpPr>
+            <a:spLocks noGrp="1" noRot="1" noChangeAspect="1"/>
+          </p:cNvSpPr>
+          <p:nvPr>
             <p:ph type="sldImg" idx="2"/>
           </p:nvPr>
         </p:nvSpPr>
@@ -1175,60 +1343,12 @@
           <a:p>
             <a:r>
               <a:rPr lang="en-US" dirty="0"/>
-              <a:t>"Three things frame this.</a:t>
-            </a:r>
-          </a:p>
-          <a:p>
-            <a:endParaRPr lang="en-US" dirty="0"/>
-          </a:p>
-          <a:p>
-            <a:r>
-              <a:rPr lang="en-US" dirty="0"/>
-              <a:t>ING is a hybrid. You carry the direct, feature-first, mobile-first tone of a neobank, and the institutional weight of a Tier-1 bank. That is a position, not an accident.</a:t>
-            </a:r>
-          </a:p>
-          <a:p>
-            <a:endParaRPr lang="en-US" dirty="0"/>
-          </a:p>
-          <a:p>
-            <a:r>
-              <a:rPr lang="en-US" dirty="0"/>
-              <a:t>The playing field is level on regulation. Neobanks' speed is architecture and no branches — not lighter European or compliance rules.</a:t>
-            </a:r>
-          </a:p>
-          <a:p>
-            <a:endParaRPr lang="en-US" dirty="0"/>
-          </a:p>
-          <a:p>
-            <a:r>
-              <a:rPr lang="en-US" dirty="0"/>
-              <a:t>Where you differ is the engine. Traditional banks use the current account as a loss leader and </a:t>
-            </a:r>
-            <a:r>
-              <a:rPr lang="en-US" dirty="0" err="1"/>
-              <a:t>monetise</a:t>
-            </a:r>
-            <a:r>
-              <a:rPr lang="en-US" dirty="0"/>
-              <a:t> later: mortgages, insurance, wealth. Neobanks </a:t>
-            </a:r>
-            <a:r>
-              <a:rPr lang="en-US" dirty="0" err="1"/>
-              <a:t>monetise</a:t>
-            </a:r>
-            <a:r>
-              <a:rPr lang="en-US" dirty="0"/>
-              <a:t> upfront — freemium tiers, subscriptions, abonnements, FX. They chase volume among young adults and digital nomads. You chase lifetime value: expats, first-time investors, first-time buyers."</a:t>
+              <a:t>"As part of the ING DACI two-week P of C, we set out to answer one question: how do Belgian banks communicate similar products on the open web, and what can ING learn from it?  To move away from subjective design opinions, we built a fully reproducible, end-to-end measurement pipeline across 14 banks and 104 features. First disclaimer before we start: we have no internal data, nothing here claims a design choice caused a commercial outcome — every recommendation is an argued hypothesis worth testing. </a:t>
             </a:r>
           </a:p>
         </p:txBody>
       </p:sp>
     </p:spTree>
-    <p:extLst>
-      <p:ext uri="{BB962C8B-B14F-4D97-AF65-F5344CB8AC3E}">
-        <p14:creationId xmlns:p14="http://schemas.microsoft.com/office/powerpoint/2010/main" val="559537629"/>
-      </p:ext>
-    </p:extLst>
   </p:cSld>
   <p:clrMapOvr>
     <a:masterClrMapping/>
@@ -1280,11 +1400,68 @@
           <a:bodyPr/>
           <a:lstStyle/>
           <a:p>
+            <a:r>
+              <a:rPr lang="en-US" dirty="0"/>
+              <a:t>ING is a hybrid. You carry the direct, feature-first, mobile-first tone of a neobank, and the institutional weight of a Tier-1 bank. That's a position, not an accident.</a:t>
+            </a:r>
+          </a:p>
+          <a:p>
             <a:endParaRPr lang="en-US" dirty="0"/>
           </a:p>
+          <a:p>
+            <a:r>
+              <a:rPr lang="en-US" dirty="0"/>
+              <a:t>The speed of the neobanks come from their architecture, faster decision loops and no branches: they don't have lighter European or compliance rules, they simply don't the same business model.</a:t>
+            </a:r>
+          </a:p>
+          <a:p>
+            <a:endParaRPr lang="en-US" dirty="0"/>
+          </a:p>
+          <a:p>
+            <a:r>
+              <a:rPr lang="en-US" dirty="0"/>
+              <a:t>Where you differ is the engine. Traditional banks use the current account as loss leader and </a:t>
+            </a:r>
+            <a:r>
+              <a:rPr lang="en-US" dirty="0" err="1"/>
+              <a:t>monetise</a:t>
+            </a:r>
+            <a:r>
+              <a:rPr lang="en-US" dirty="0"/>
+              <a:t> later through mortgages, insurance, wealth </a:t>
+            </a:r>
+            <a:r>
+              <a:rPr lang="en-US" dirty="0" err="1"/>
+              <a:t>managmt</a:t>
+            </a:r>
+            <a:r>
+              <a:rPr lang="en-US" dirty="0"/>
+              <a:t>... Neobanks </a:t>
+            </a:r>
+            <a:r>
+              <a:rPr lang="en-US" dirty="0" err="1"/>
+              <a:t>monetise</a:t>
+            </a:r>
+            <a:r>
+              <a:rPr lang="en-US" dirty="0"/>
+              <a:t> upfront — freemium tiers, free or paid subscriptions, abonnements, FX. They chase volume among young adults and digital nomads. You chase lifetime value: expats, first-time investors and buyers, high net worth individuals.</a:t>
+            </a:r>
+            <a:br>
+              <a:rPr lang="en-US" dirty="0"/>
+            </a:br>
+            <a:r>
+              <a:rPr lang="en-US" dirty="0"/>
+              <a:t>So, the question ….</a:t>
+            </a:r>
+          </a:p>
         </p:txBody>
       </p:sp>
     </p:spTree>
+    <p:extLst>
+      <p:ext uri="{BB962C8B-B14F-4D97-AF65-F5344CB8AC3E}">
+        <p14:creationId xmlns:p14="http://schemas.microsoft.com/office/powerpoint/2010/main" val="559537629"/>
+      </p:ext>
+    </p:extLst>
   </p:cSld>
   <p:clrMapOvr>
     <a:masterClrMapping/>
@@ -1335,7 +1512,9 @@
         <p:txBody>
           <a:bodyPr/>
           <a:lstStyle/>
-          <a:p/>
+          <a:p>
+            <a:endParaRPr lang="en-US" dirty="0"/>
+          </a:p>
         </p:txBody>
       </p:sp>
     </p:spTree>
@@ -1390,26 +1569,7 @@
           <a:bodyPr/>
           <a:lstStyle/>
           <a:p>
-            <a:endParaRPr lang="en-US" dirty="0"/>
-          </a:p>
-          <a:p>
-            <a:r>
-              <a:rPr lang="en-US" dirty="0"/>
-              <a:t>"So the question is whether that hybrid position shows up in how you actually communicate.</a:t>
-            </a:r>
-          </a:p>
-          <a:p>
-            <a:r>
-              <a:rPr lang="en-US" dirty="0"/>
-              <a:t>51 pages, 14 banks, 6 product families, 104 documented features. We only ever compare within one product family — pages do different jobs. The headline runs on 18 current-account pages, 14 banks.</a:t>
-            </a:r>
-          </a:p>
-          <a:p>
-            <a:r>
-              <a:rPr lang="en-US" dirty="0"/>
-              <a:t>Deciding what was relevant was part of the work."</a:t>
-            </a:r>
-            <a:endParaRPr dirty="0"/>
+            <a:endParaRPr/>
           </a:p>
         </p:txBody>
       </p:sp>
@@ -1467,6 +1627,25 @@
           <a:p>
             <a:endParaRPr lang="en-US" dirty="0"/>
           </a:p>
+          <a:p>
+            <a:r>
+              <a:rPr lang="en-US" dirty="0"/>
+              <a:t>"So the question is whether that hybrid position shows up in how you actually communicate.</a:t>
+            </a:r>
+          </a:p>
+          <a:p>
+            <a:r>
+              <a:rPr lang="en-US" dirty="0"/>
+              <a:t>51 pages, 14 banks, 6 product families, 104 documented features. We only ever compare within one product family — pages do different jobs. The headline runs on 18 current-account pages, 14 banks.</a:t>
+            </a:r>
+          </a:p>
+          <a:p>
+            <a:r>
+              <a:rPr lang="en-US" dirty="0"/>
+              <a:t>Deciding what was relevant was part of the work."</a:t>
+            </a:r>
+            <a:endParaRPr dirty="0"/>
+          </a:p>
         </p:txBody>
       </p:sp>
     </p:spTree>
@@ -1520,7 +1699,9 @@
         <p:txBody>
           <a:bodyPr/>
           <a:lstStyle/>
-          <a:p/>
+          <a:p>
+            <a:endParaRPr lang="en-US" dirty="0"/>
+          </a:p>
         </p:txBody>
       </p:sp>
     </p:spTree>
@@ -1555,7 +1736,7 @@
             <a:spLocks noGrp="1" noRot="1" noChangeAspect="1"/>
           </p:cNvSpPr>
           <p:nvPr>
-            <p:ph type="sldImg" idx="2"/>
+            <p:ph type="sldImg"/>
           </p:nvPr>
         </p:nvSpPr>
         <p:spPr/>
@@ -1567,7 +1748,7 @@
             <a:spLocks noGrp="1"/>
           </p:cNvSpPr>
           <p:nvPr>
-            <p:ph type="body" sz="quarter" idx="3"/>
+            <p:ph type="body" idx="1"/>
           </p:nvPr>
         </p:nvSpPr>
         <p:spPr/>
@@ -1575,58 +1756,9 @@
           <a:bodyPr/>
           <a:lstStyle/>
           <a:p>
-            <a:r>
-              <a:t>BRIDGE from slides 9–11: incumbents hold 97.6% of brand search, challengers 2.3%. This slide is the caveat before anyone reads that as market share.</a:t>
-            </a:r>
-          </a:p>
-          <a:p>
-            <a:r>
-              <a:t>THE CONTRAST: Revolut reports more than 1 million private customers in Belgium, adding about 25,000 a month (Belga News Agency, 11 Mar 2026) — yet holds 1.64% of brand search, 9th of 14. Both are true; they measure different things.</a:t>
-            </a:r>
-          </a:p>
-          <a:p>
-            <a:r>
-              <a:t>THREE REASONS search undercounts a challenger — none of them is "Revolut is small":</a:t>
-            </a:r>
-          </a:p>
-          <a:p>
-            <a:r>
-              <a:t>1. Navigational searches. Incumbents are searched for logins, branches, opening hours. Say it as a working hypothesis — not verified at query level.</a:t>
-            </a:r>
-          </a:p>
-          <a:p>
-            <a:r>
-              <a:t>2. App-first journeys. Sign-up through app stores and referral links, then daily use inside the app; the brand name is never typed.</a:t>
-            </a:r>
-          </a:p>
-          <a:p>
-            <a:r>
-              <a:t>3. Measurement floor. Six of the 14 brands never clear 10/100 in their own Trends request, so their share is partly rounding. Revolut itself is above the floor (peak 19), so its 1.64% is a real reading.</a:t>
-            </a:r>
-          </a:p>
-          <a:p>
-            <a:r>
-              <a:t>LAND: challenger shares are a floor on attention, not a customer count. The 1M figure is deliberately never set against a market-share figure.</a:t>
-            </a:r>
-          </a:p>
-          <a:p>
-            <a:r>
-              <a:t>TRANSITION: search tells us who gets attention, not who wins. From here on we stop measuring and start advising.</a:t>
-            </a:r>
-          </a:p>
-        </p:txBody>
-      </p:sp>
-      <p:sp>
-        <p:nvSpPr>
-          <p:cNvPr id="4" name="Slide Number Placeholder 3"/>
-          <p:cNvSpPr>
-            <a:spLocks noGrp="1"/>
-          </p:cNvSpPr>
-          <p:nvPr>
-            <p:ph type="sldNum" sz="quarter" idx="5"/>
-          </p:nvPr>
-        </p:nvSpPr>
-        <p:spPr/>
+            <a:endParaRPr/>
+          </a:p>
+        </p:txBody>
       </p:sp>
     </p:spTree>
   </p:cSld>
@@ -1681,42 +1813,42 @@
           <a:lstStyle/>
           <a:p>
             <a:r>
-              <a:t>WALK THE CARD (R1, top): title and priority · WHAT THE DATA SHOWS — the finding with its numbers: 4.0 urgency markers per page vs a peer mean of 0.64, about 3.7 SD · WHAT TO DO — the action · chips: the feature it was argued from (urgency_marker_count) and the pages it applies to.</a:t>
-            </a:r>
-          </a:p>
-          <a:p>
-            <a:r>
-              <a:t>THREE GUARDRAILS (right column):</a:t>
-            </a:r>
-          </a:p>
-          <a:p>
-            <a:r>
-              <a:t>1. Finding and action kept apart. Anyone can reject the action and keep the finding — nobody has to buy the advice to accept the measurement.</a:t>
-            </a:r>
-          </a:p>
-          <a:p>
-            <a:r>
-              <a:t>2. Named features, checked before release. Every feature id on a card is verified against the report; an id the model invented is dropped before the list is shown.</a:t>
-            </a:r>
-          </a:p>
-          <a:p>
-            <a:r>
-              <a:t>3. No figure the analysis did not produce. The prompt receives only numbers already in the report; the output is not trusted to add any.</a:t>
-            </a:r>
-          </a:p>
-          <a:p>
-            <a:r>
-              <a:t>ONE LINE: the model is a writer, not a source.</a:t>
-            </a:r>
-          </a:p>
-          <a:p>
-            <a:r>
-              <a:t>IF ASKED about R2 in the screenshot ("Repeat the primary call to action"): it rests on cta_count, withdrawn on 23/09 — the captured HTML holds every pack card, but no counting rule reproduced a human count across the fourteen banks, so the figure would have reported markup convention rather than the page. A recommendation dying with its feature is the mechanism working. The screenshot predates the withdrawal.</a:t>
-            </a:r>
-          </a:p>
-          <a:p>
-            <a:r>
-              <a:t>TRANSITION: so what did it conclude about ING?</a:t>
+              <a:t>BRIDGE from slides 9–11: incumbents hold 97.6% of brand search, challengers 2.3%. This slide is the caveat before anyone reads that as market share.</a:t>
+            </a:r>
+          </a:p>
+          <a:p>
+            <a:r>
+              <a:t>THE CONTRAST: Revolut reports more than 1 million private customers in Belgium, adding about 25,000 a month (Belga News Agency, 11 Mar 2026) — yet holds 1.64% of brand search, 9th of 14. Both are true; they measure different things.</a:t>
+            </a:r>
+          </a:p>
+          <a:p>
+            <a:r>
+              <a:t>THREE REASONS search undercounts a challenger — none of them is "Revolut is small":</a:t>
+            </a:r>
+          </a:p>
+          <a:p>
+            <a:r>
+              <a:t>1. Navigational searches. Incumbents are searched for logins, branches, opening hours. Say it as a working hypothesis — not verified at query level.</a:t>
+            </a:r>
+          </a:p>
+          <a:p>
+            <a:r>
+              <a:t>2. App-first journeys. Sign-up through app stores and referral links, then daily use inside the app; the brand name is never typed.</a:t>
+            </a:r>
+          </a:p>
+          <a:p>
+            <a:r>
+              <a:t>3. Measurement floor. Six of the 14 brands never clear 10/100 in their own Trends request, so their share is partly rounding. Revolut itself is above the floor (peak 19), so its 1.64% is a real reading.</a:t>
+            </a:r>
+          </a:p>
+          <a:p>
+            <a:r>
+              <a:t>LAND: challenger shares are a floor on attention, not a customer count. The 1M figure is deliberately never set against a market-share figure.</a:t>
+            </a:r>
+          </a:p>
+          <a:p>
+            <a:r>
+              <a:t>TRANSITION: search tells us who gets attention, not who wins. From here on we stop measuring and start advising.</a:t>
             </a:r>
           </a:p>
         </p:txBody>
@@ -1920,7 +2052,7 @@
           <a:p>
             <a:fld id="{5BCAD085-E8A6-8845-BD4E-CB4CCA059FC4}" type="datetimeFigureOut">
               <a:rPr lang="en-US" smtClean="0"/>
-              <a:t>9/25/26</a:t>
+              <a:t>9/25/2026</a:t>
             </a:fld>
             <a:endParaRPr lang="en-US"/>
           </a:p>
@@ -2088,7 +2220,7 @@
           <a:p>
             <a:fld id="{5BCAD085-E8A6-8845-BD4E-CB4CCA059FC4}" type="datetimeFigureOut">
               <a:rPr lang="en-US" smtClean="0"/>
-              <a:t>9/25/26</a:t>
+              <a:t>9/25/2026</a:t>
             </a:fld>
             <a:endParaRPr lang="en-US"/>
           </a:p>
@@ -2266,7 +2398,7 @@
           <a:p>
             <a:fld id="{5BCAD085-E8A6-8845-BD4E-CB4CCA059FC4}" type="datetimeFigureOut">
               <a:rPr lang="en-US" smtClean="0"/>
-              <a:t>9/25/26</a:t>
+              <a:t>9/25/2026</a:t>
             </a:fld>
             <a:endParaRPr lang="en-US"/>
           </a:p>
@@ -2464,7 +2596,7 @@
           <a:p>
             <a:fld id="{5BCAD085-E8A6-8845-BD4E-CB4CCA059FC4}" type="datetimeFigureOut">
               <a:rPr lang="en-US" smtClean="0"/>
-              <a:t>9/25/26</a:t>
+              <a:t>9/25/2026</a:t>
             </a:fld>
             <a:endParaRPr lang="en-US"/>
           </a:p>
@@ -2709,7 +2841,7 @@
           <a:p>
             <a:fld id="{5BCAD085-E8A6-8845-BD4E-CB4CCA059FC4}" type="datetimeFigureOut">
               <a:rPr lang="en-US" smtClean="0"/>
-              <a:t>9/25/26</a:t>
+              <a:t>9/25/2026</a:t>
             </a:fld>
             <a:endParaRPr lang="en-US"/>
           </a:p>
@@ -2994,7 +3126,7 @@
           <a:p>
             <a:fld id="{5BCAD085-E8A6-8845-BD4E-CB4CCA059FC4}" type="datetimeFigureOut">
               <a:rPr lang="en-US" smtClean="0"/>
-              <a:t>9/25/26</a:t>
+              <a:t>9/25/2026</a:t>
             </a:fld>
             <a:endParaRPr lang="en-US"/>
           </a:p>
@@ -3413,7 +3545,7 @@
           <a:p>
             <a:fld id="{5BCAD085-E8A6-8845-BD4E-CB4CCA059FC4}" type="datetimeFigureOut">
               <a:rPr lang="en-US" smtClean="0"/>
-              <a:t>9/25/26</a:t>
+              <a:t>9/25/2026</a:t>
             </a:fld>
             <a:endParaRPr lang="en-US"/>
           </a:p>
@@ -3530,7 +3662,7 @@
           <a:p>
             <a:fld id="{5BCAD085-E8A6-8845-BD4E-CB4CCA059FC4}" type="datetimeFigureOut">
               <a:rPr lang="en-US" smtClean="0"/>
-              <a:t>9/25/26</a:t>
+              <a:t>9/25/2026</a:t>
             </a:fld>
             <a:endParaRPr lang="en-US"/>
           </a:p>
@@ -3625,7 +3757,7 @@
           <a:p>
             <a:fld id="{5BCAD085-E8A6-8845-BD4E-CB4CCA059FC4}" type="datetimeFigureOut">
               <a:rPr lang="en-US" smtClean="0"/>
-              <a:t>9/25/26</a:t>
+              <a:t>9/25/2026</a:t>
             </a:fld>
             <a:endParaRPr lang="en-US"/>
           </a:p>
@@ -3900,7 +4032,7 @@
           <a:p>
             <a:fld id="{5BCAD085-E8A6-8845-BD4E-CB4CCA059FC4}" type="datetimeFigureOut">
               <a:rPr lang="en-US" smtClean="0"/>
-              <a:t>9/25/26</a:t>
+              <a:t>9/25/2026</a:t>
             </a:fld>
             <a:endParaRPr lang="en-US"/>
           </a:p>
@@ -4152,7 +4284,7 @@
           <a:p>
             <a:fld id="{5BCAD085-E8A6-8845-BD4E-CB4CCA059FC4}" type="datetimeFigureOut">
               <a:rPr lang="en-US" smtClean="0"/>
-              <a:t>9/25/26</a:t>
+              <a:t>9/25/2026</a:t>
             </a:fld>
             <a:endParaRPr lang="en-US"/>
           </a:p>
@@ -4363,7 +4495,7 @@
           <a:p>
             <a:fld id="{5BCAD085-E8A6-8845-BD4E-CB4CCA059FC4}" type="datetimeFigureOut">
               <a:rPr lang="en-US" smtClean="0"/>
-              <a:t>9/25/26</a:t>
+              <a:t>9/25/2026</a:t>
             </a:fld>
             <a:endParaRPr lang="en-US"/>
           </a:p>
@@ -14339,7 +14471,7 @@
         </p:nvSpPr>
         <p:spPr>
           <a:xfrm>
-            <a:off x="822960" y="2743200"/>
+            <a:off x="822960" y="2926080"/>
             <a:ext cx="2011680" cy="91440"/>
           </a:xfrm>
           <a:prstGeom prst="rect">
@@ -14426,7 +14558,7 @@
         </p:nvSpPr>
         <p:spPr>
           <a:xfrm>
-            <a:off x="822960" y="3063240"/>
+            <a:off x="822960" y="3291840"/>
             <a:ext cx="10058400" cy="1463040"/>
           </a:xfrm>
           <a:prstGeom prst="rect">
@@ -14449,7 +14581,7 @@
               </a:spcAft>
             </a:pPr>
             <a:r>
-              <a:rPr sz="1400" b="0">
+              <a:rPr sz="1400" b="0" dirty="0">
                 <a:solidFill>
                   <a:srgbClr val="B8B8C8"/>
                 </a:solidFill>
@@ -14468,7 +14600,7 @@
               </a:spcAft>
             </a:pPr>
             <a:r>
-              <a:rPr sz="1400" b="0">
+              <a:rPr sz="1400" b="0" dirty="0">
                 <a:solidFill>
                   <a:srgbClr val="B8B8C8"/>
                 </a:solidFill>

</xml_diff>